<commit_message>
[scholar] GEB 7911 Week 7 prep (Ch. 10 mapped to the study); poster career-length line removed
Co-Authored-By: Claude Opus 5.5 <noreply@anthropic.com>
Claude-Session: https://claude.ai/code/session_019uQWfMoV11me5yJ6LYRtPv
</commit_message>
<xml_diff>
--- a/dba/coursework/GEB7911_Qualitative_Research_Methods/Malik_GEB7911_ProposalPoster_DRAFT.pptx
+++ b/dba/coursework/GEB7911_Qualitative_Research_Methods/Malik_GEB7911_ProposalPoster_DRAFT.pptx
@@ -4882,7 +4882,7 @@
         <p:spPr>
           <a:xfrm>
             <a:off x="3298825" y="3054934"/>
-            <a:ext cx="2740025" cy="437388"/>
+            <a:ext cx="2740025" cy="563118"/>
           </a:xfrm>
           <a:prstGeom prst="rect">
             <a:avLst/>
@@ -4912,7 +4912,7 @@
                 <a:latin typeface="Times New Roman"/>
                 <a:cs typeface="Times New Roman"/>
               </a:rPr>
-              <a:t>Fifteen years in audit and risk, and prior bank examination work.</a:t>
+              <a:t>A career in bank examination, regulatory reporting and internal</a:t>
             </a:r>
           </a:p>
           <a:p>
@@ -4935,7 +4935,7 @@
                 <a:latin typeface="Times New Roman"/>
                 <a:cs typeface="Times New Roman"/>
               </a:rPr>
-              <a:t>Insider access and insider bias at once. Every occasion of feeling</a:t>
+              <a:t>audit, including building an AI review tool. Insider access and</a:t>
             </a:r>
           </a:p>
           <a:p>
@@ -4958,7 +4958,30 @@
                 <a:latin typeface="Times New Roman"/>
                 <a:cs typeface="Times New Roman"/>
               </a:rPr>
-              <a:t>confirmed is entered in a confirmation hazard log.</a:t>
+              <a:t>insider bias at once. Every occasion of feeling confirmed is entered</a:t>
+            </a:r>
+          </a:p>
+          <a:p>
+            <a:pPr algn="l">
+              <a:lnSpc>
+                <a:spcPts val="990"/>
+              </a:lnSpc>
+              <a:spcBef>
+                <a:spcPts val="0"/>
+              </a:spcBef>
+              <a:spcAft>
+                <a:spcPts val="0"/>
+              </a:spcAft>
+            </a:pPr>
+            <a:r>
+              <a:rPr sz="790" b="0" i="0">
+                <a:solidFill>
+                  <a:srgbClr val="3A4048"/>
+                </a:solidFill>
+                <a:latin typeface="Times New Roman"/>
+                <a:cs typeface="Times New Roman"/>
+              </a:rPr>
+              <a:t>in a confirmation hazard log.</a:t>
             </a:r>
           </a:p>
         </p:txBody>
@@ -4971,7 +4994,7 @@
         </p:nvSpPr>
         <p:spPr>
           <a:xfrm>
-            <a:off x="3298825" y="3485896"/>
+            <a:off x="3298825" y="3611626"/>
             <a:ext cx="982980" cy="133350"/>
           </a:xfrm>
           <a:prstGeom prst="rect">
@@ -5015,7 +5038,7 @@
         </p:nvSpPr>
         <p:spPr>
           <a:xfrm>
-            <a:off x="3298825" y="3597224"/>
+            <a:off x="3298825" y="3722954"/>
             <a:ext cx="2740025" cy="311658"/>
           </a:xfrm>
           <a:prstGeom prst="rect">
@@ -5082,7 +5105,7 @@
         </p:nvSpPr>
         <p:spPr>
           <a:xfrm>
-            <a:off x="3298825" y="3938270"/>
+            <a:off x="3298825" y="4064000"/>
             <a:ext cx="2727325" cy="177800"/>
           </a:xfrm>
           <a:prstGeom prst="roundRect">
@@ -5114,7 +5137,7 @@
         </p:nvSpPr>
         <p:spPr>
           <a:xfrm>
-            <a:off x="3400425" y="3952595"/>
+            <a:off x="3400425" y="4078325"/>
             <a:ext cx="1740408" cy="137160"/>
           </a:xfrm>
           <a:prstGeom prst="rect">
@@ -5158,7 +5181,7 @@
         </p:nvSpPr>
         <p:spPr>
           <a:xfrm>
-            <a:off x="3298825" y="4153154"/>
+            <a:off x="3298825" y="4278884"/>
             <a:ext cx="2740025" cy="445769"/>
           </a:xfrm>
           <a:prstGeom prst="rect">
@@ -5248,7 +5271,7 @@
         </p:nvSpPr>
         <p:spPr>
           <a:xfrm>
-            <a:off x="3311525" y="4653280"/>
+            <a:off x="3311525" y="4779010"/>
             <a:ext cx="40640" cy="40640"/>
           </a:xfrm>
           <a:prstGeom prst="roundRect">
@@ -5280,7 +5303,7 @@
         </p:nvSpPr>
         <p:spPr>
           <a:xfrm>
-            <a:off x="3413125" y="4588764"/>
+            <a:off x="3413125" y="4714494"/>
             <a:ext cx="2625725" cy="317500"/>
           </a:xfrm>
           <a:prstGeom prst="rect">
@@ -5347,7 +5370,7 @@
         </p:nvSpPr>
         <p:spPr>
           <a:xfrm>
-            <a:off x="3311525" y="4947920"/>
+            <a:off x="3311525" y="5073650"/>
             <a:ext cx="40640" cy="40640"/>
           </a:xfrm>
           <a:prstGeom prst="roundRect">
@@ -5379,7 +5402,7 @@
         </p:nvSpPr>
         <p:spPr>
           <a:xfrm>
-            <a:off x="3413125" y="4883404"/>
+            <a:off x="3413125" y="5009134"/>
             <a:ext cx="2625725" cy="317500"/>
           </a:xfrm>
           <a:prstGeom prst="rect">
@@ -5446,7 +5469,7 @@
         </p:nvSpPr>
         <p:spPr>
           <a:xfrm>
-            <a:off x="3311525" y="5242560"/>
+            <a:off x="3311525" y="5368290"/>
             <a:ext cx="40640" cy="40640"/>
           </a:xfrm>
           <a:prstGeom prst="roundRect">
@@ -5478,7 +5501,7 @@
         </p:nvSpPr>
         <p:spPr>
           <a:xfrm>
-            <a:off x="3413125" y="5178044"/>
+            <a:off x="3413125" y="5303774"/>
             <a:ext cx="2625725" cy="189229"/>
           </a:xfrm>
           <a:prstGeom prst="rect">

</xml_diff>

<commit_message>
[scholar] GEB 7911 poster + three-slide appendix (sampling, analysis, validation, questions for feedback); eligibility aligned to protocol
Co-Authored-By: Claude Opus 5.5 <noreply@anthropic.com>
Claude-Session: https://claude.ai/code/session_019uQWfMoV11me5yJ6LYRtPv
</commit_message>
<xml_diff>
--- a/dba/coursework/GEB7911_Qualitative_Research_Methods/Malik_GEB7911_ProposalPoster_DRAFT.pptx
+++ b/dba/coursework/GEB7911_Qualitative_Research_Methods/Malik_GEB7911_ProposalPoster_DRAFT.pptx
@@ -5818,7 +5818,7 @@
                 <a:latin typeface="Times New Roman"/>
                 <a:cs typeface="Times New Roman"/>
               </a:rPr>
-              <a:t>Eight or more years internal audit, recurring engagement</a:t>
+              <a:t>Five or more years in audit or risk assurance, with recurring</a:t>
             </a:r>
           </a:p>
           <a:p>
@@ -5841,7 +5841,7 @@
                 <a:latin typeface="Times New Roman"/>
                 <a:cs typeface="Times New Roman"/>
               </a:rPr>
-              <a:t>responsibility</a:t>
+              <a:t>engagement responsibility</a:t>
             </a:r>
           </a:p>
         </p:txBody>

</xml_diff>

<commit_message>
[scholar] GEB 7911 poster: one page for public display, template headings, validation line; appendix version retired
Co-Authored-By: Claude Opus 5.5 <noreply@anthropic.com>
Claude-Session: https://claude.ai/code/session_019uQWfMoV11me5yJ6LYRtPv
</commit_message>
<xml_diff>
--- a/dba/coursework/GEB7911_Qualitative_Research_Methods/Malik_GEB7911_ProposalPoster_DRAFT.pptx
+++ b/dba/coursework/GEB7911_Qualitative_Research_Methods/Malik_GEB7911_ProposalPoster_DRAFT.pptx
@@ -3370,8 +3370,8 @@
         </p:nvSpPr>
         <p:spPr>
           <a:xfrm>
-            <a:off x="10053447" y="424180"/>
-            <a:ext cx="1706753" cy="190500"/>
+            <a:off x="8783701" y="424180"/>
+            <a:ext cx="2976499" cy="190500"/>
           </a:xfrm>
           <a:prstGeom prst="rect">
             <a:avLst/>
@@ -3401,7 +3401,7 @@
                 <a:latin typeface="Times New Roman"/>
                 <a:cs typeface="Times New Roman"/>
               </a:rPr>
-              <a:t>DBA Cohort 8.14  ·  GEB 7911</a:t>
+              <a:t>DBA Cohort 8.14  ·  GEB 7911  ·  Dr. Cristina Gonzalez</a:t>
             </a:r>
           </a:p>
         </p:txBody>
@@ -3414,8 +3414,8 @@
         </p:nvSpPr>
         <p:spPr>
           <a:xfrm>
-            <a:off x="8851011" y="627380"/>
-            <a:ext cx="2909189" cy="190500"/>
+            <a:off x="9294876" y="660704"/>
+            <a:ext cx="2465324" cy="144779"/>
           </a:xfrm>
           <a:prstGeom prst="rect">
             <a:avLst/>
@@ -3438,14 +3438,14 @@
               </a:spcAft>
             </a:pPr>
             <a:r>
-              <a:rPr sz="1000" b="0" i="0">
-                <a:solidFill>
-                  <a:srgbClr val="8FA3BC"/>
-                </a:solidFill>
-                <a:latin typeface="Times New Roman"/>
-                <a:cs typeface="Times New Roman"/>
-              </a:rPr>
-              <a:t>Qualitative Research Proposal  ·  Dr. Cristina Gonzalez</a:t>
+              <a:rPr sz="760" b="1" i="0" spc="100">
+                <a:solidFill>
+                  <a:srgbClr val="B6862C"/>
+                </a:solidFill>
+                <a:latin typeface="Consolas"/>
+                <a:cs typeface="Consolas"/>
+              </a:rPr>
+              <a:t>DRAFT FOR FEEDBACK  ·  29 SEP 2026</a:t>
             </a:r>
           </a:p>
         </p:txBody>
@@ -3523,7 +3523,7 @@
         <p:spPr>
           <a:xfrm>
             <a:off x="660400" y="1169035"/>
-            <a:ext cx="1962150" cy="142875"/>
+            <a:ext cx="1352550" cy="142875"/>
           </a:xfrm>
           <a:prstGeom prst="rect">
             <a:avLst/>
@@ -3553,7 +3553,7 @@
                 <a:latin typeface="Consolas"/>
                 <a:cs typeface="Consolas"/>
               </a:rPr>
-              <a:t>CENTRAL RESEARCH QUESTION</a:t>
+              <a:t>RESEARCH QUESTION</a:t>
             </a:r>
           </a:p>
         </p:txBody>
@@ -3643,7 +3643,7 @@
         <p:spPr>
           <a:xfrm>
             <a:off x="533400" y="1766925"/>
-            <a:ext cx="2161031" cy="137160"/>
+            <a:ext cx="1530096" cy="137160"/>
           </a:xfrm>
           <a:prstGeom prst="rect">
             <a:avLst/>
@@ -3673,7 +3673,7 @@
                 <a:latin typeface="Consolas"/>
                 <a:cs typeface="Consolas"/>
               </a:rPr>
-              <a:t>1 · FOCUS AND RESEARCH PROBLEM</a:t>
+              <a:t>1 · PROBLEM STATEMENT</a:t>
             </a:r>
           </a:p>
         </p:txBody>
@@ -4102,7 +4102,7 @@
         <p:spPr>
           <a:xfrm>
             <a:off x="533400" y="3904335"/>
-            <a:ext cx="1459992" cy="137160"/>
+            <a:ext cx="1530096" cy="137160"/>
           </a:xfrm>
           <a:prstGeom prst="rect">
             <a:avLst/>
@@ -4132,7 +4132,7 @@
                 <a:latin typeface="Consolas"/>
                 <a:cs typeface="Consolas"/>
               </a:rPr>
-              <a:t>2 · RESEARCH PURPOSE</a:t>
+              <a:t>2 · PURPOSE STATEMENT</a:t>
             </a:r>
           </a:p>
         </p:txBody>
@@ -4558,7 +4558,7 @@
                 <a:latin typeface="Consolas"/>
                 <a:cs typeface="Consolas"/>
               </a:rPr>
-              <a:t>3 · FRAMEWORK AND ASSUMPTIONS</a:t>
+              <a:t>3 · PHILOSOPHICAL ASSUMPTIONS</a:t>
             </a:r>
           </a:p>
         </p:txBody>
@@ -5138,7 +5138,7 @@
         <p:spPr>
           <a:xfrm>
             <a:off x="3400425" y="4078325"/>
-            <a:ext cx="1740408" cy="137160"/>
+            <a:ext cx="1810512" cy="137160"/>
           </a:xfrm>
           <a:prstGeom prst="rect">
             <a:avLst/>
@@ -5168,7 +5168,7 @@
                 <a:latin typeface="Consolas"/>
                 <a:cs typeface="Consolas"/>
               </a:rPr>
-              <a:t>4 · QUALITATIVE APPROACH</a:t>
+              <a:t>4 · METHODOLOGY: APPROACH</a:t>
             </a:r>
           </a:p>
         </p:txBody>
@@ -5578,7 +5578,7 @@
         <p:spPr>
           <a:xfrm>
             <a:off x="6267450" y="1766925"/>
-            <a:ext cx="1389888" cy="137160"/>
+            <a:ext cx="2301240" cy="137160"/>
           </a:xfrm>
           <a:prstGeom prst="rect">
             <a:avLst/>
@@ -5608,7 +5608,7 @@
                 <a:latin typeface="Consolas"/>
                 <a:cs typeface="Consolas"/>
               </a:rPr>
-              <a:t>5 · DATA COLLECTION</a:t>
+              <a:t>5 · METHODOLOGY: DATA COLLECTION</a:t>
             </a:r>
           </a:p>
         </p:txBody>
@@ -6306,7 +6306,7 @@
         <p:spPr>
           <a:xfrm>
             <a:off x="6267450" y="4197705"/>
-            <a:ext cx="1249680" cy="137160"/>
+            <a:ext cx="2161031" cy="137160"/>
           </a:xfrm>
           <a:prstGeom prst="rect">
             <a:avLst/>
@@ -6336,7 +6336,7 @@
                 <a:latin typeface="Consolas"/>
                 <a:cs typeface="Consolas"/>
               </a:rPr>
-              <a:t>6 · DATA ANALYSIS</a:t>
+              <a:t>6 · METHODOLOGY: DATA ANALYSIS</a:t>
             </a:r>
           </a:p>
         </p:txBody>
@@ -6958,7 +6958,7 @@
         <p:spPr>
           <a:xfrm>
             <a:off x="9134475" y="1766925"/>
-            <a:ext cx="1880615" cy="137160"/>
+            <a:ext cx="1810512" cy="137160"/>
           </a:xfrm>
           <a:prstGeom prst="rect">
             <a:avLst/>
@@ -6988,7 +6988,7 @@
                 <a:latin typeface="Consolas"/>
                 <a:cs typeface="Consolas"/>
               </a:rPr>
-              <a:t>7 · ETHICAL CONSIDERATIONS</a:t>
+              <a:t>7 · ETHICS AND VALIDATION</a:t>
             </a:r>
           </a:p>
         </p:txBody>
@@ -7391,7 +7391,7 @@
                 <a:latin typeface="Times New Roman"/>
                 <a:cs typeface="Times New Roman"/>
               </a:rPr>
-              <a:t>Member checking of the composite description offered to every</a:t>
+              <a:t>Validation: confirmation hazard log, disconfirming cases,</a:t>
             </a:r>
           </a:p>
           <a:p>
@@ -7414,7 +7414,7 @@
                 <a:latin typeface="Times New Roman"/>
                 <a:cs typeface="Times New Roman"/>
               </a:rPr>
-              <a:t>participant</a:t>
+              <a:t>member checking, audit trail</a:t>
             </a:r>
           </a:p>
         </p:txBody>
@@ -7589,7 +7589,7 @@
                 <a:latin typeface="Consolas"/>
                 <a:cs typeface="Consolas"/>
               </a:rPr>
-              <a:t>8 · EXPECTED CONTRIBUTION</a:t>
+              <a:t>8 · DESIRED CONTRIBUTIONS</a:t>
             </a:r>
           </a:p>
         </p:txBody>

</xml_diff>

<commit_message>
[scholar] poster: soften the gap claim; correct Fotoh title; complete Glickman and Murikah references
Co-Authored-By: Claude Opus 5.5 <noreply@anthropic.com>
Claude-Session: https://claude.ai/code/session_019uQWfMoV11me5yJ6LYRtPv
</commit_message>
<xml_diff>
--- a/dba/coursework/GEB7911_Qualitative_Research_Methods/Malik_GEB7911_ProposalPoster_DRAFT.pptx
+++ b/dba/coursework/GEB7911_Qualitative_Research_Methods/Malik_GEB7911_ProposalPoster_DRAFT.pptx
@@ -3876,7 +3876,7 @@
                 <a:latin typeface="Times New Roman"/>
                 <a:cs typeface="Times New Roman"/>
               </a:rPr>
-              <a:t>already formed remains unexplored.</a:t>
+              <a:t>already formed has received much less attention.</a:t>
             </a:r>
           </a:p>
         </p:txBody>
@@ -7883,7 +7883,7 @@
         <p:spPr>
           <a:xfrm>
             <a:off x="6604000" y="6203188"/>
-            <a:ext cx="2489200" cy="205740"/>
+            <a:ext cx="2489200" cy="285750"/>
           </a:xfrm>
           <a:prstGeom prst="rect">
             <a:avLst/>
@@ -7913,7 +7913,7 @@
                 <a:latin typeface="Times New Roman"/>
                 <a:cs typeface="Times New Roman"/>
               </a:rPr>
-              <a:t>Fotoh, L. E., &amp; Mugwira, T. (2025). Exploring the impact of generative AI on</a:t>
+              <a:t>Fotoh, L. E., &amp; Mugwira, T. (2025). Exploring large language models in</a:t>
             </a:r>
           </a:p>
           <a:p>
@@ -7936,7 +7936,30 @@
                 <a:latin typeface="Times New Roman"/>
                 <a:cs typeface="Times New Roman"/>
               </a:rPr>
-              <a:t>professional skepticism in auditing.</a:t>
+              <a:t>external audits: Implications and ethical considerations. International Journal of</a:t>
+            </a:r>
+          </a:p>
+          <a:p>
+            <a:pPr algn="l">
+              <a:lnSpc>
+                <a:spcPts val="630"/>
+              </a:lnSpc>
+              <a:spcBef>
+                <a:spcPts val="0"/>
+              </a:spcBef>
+              <a:spcAft>
+                <a:spcPts val="0"/>
+              </a:spcAft>
+            </a:pPr>
+            <a:r>
+              <a:rPr sz="600" b="0" i="0">
+                <a:solidFill>
+                  <a:srgbClr val="767D86"/>
+                </a:solidFill>
+                <a:latin typeface="Times New Roman"/>
+                <a:cs typeface="Times New Roman"/>
+              </a:rPr>
+              <a:t>Accounting Information Systems, 56, 100748.</a:t>
             </a:r>
           </a:p>
         </p:txBody>
@@ -7950,7 +7973,7 @@
         <p:spPr>
           <a:xfrm>
             <a:off x="9182100" y="6203188"/>
-            <a:ext cx="2489200" cy="205740"/>
+            <a:ext cx="2489200" cy="285750"/>
           </a:xfrm>
           <a:prstGeom prst="rect">
             <a:avLst/>
@@ -8003,7 +8026,30 @@
                 <a:latin typeface="Times New Roman"/>
                 <a:cs typeface="Times New Roman"/>
               </a:rPr>
-              <a:t>perceptual, emotional and social judgements.</a:t>
+              <a:t>perceptual, emotional and social judgements. Nature Human Behaviour, 9(2),</a:t>
+            </a:r>
+          </a:p>
+          <a:p>
+            <a:pPr algn="l">
+              <a:lnSpc>
+                <a:spcPts val="630"/>
+              </a:lnSpc>
+              <a:spcBef>
+                <a:spcPts val="0"/>
+              </a:spcBef>
+              <a:spcAft>
+                <a:spcPts val="0"/>
+              </a:spcAft>
+            </a:pPr>
+            <a:r>
+              <a:rPr sz="600" b="0" i="0">
+                <a:solidFill>
+                  <a:srgbClr val="767D86"/>
+                </a:solidFill>
+                <a:latin typeface="Times New Roman"/>
+                <a:cs typeface="Times New Roman"/>
+              </a:rPr>
+              <a:t>345-359.</a:t>
             </a:r>
           </a:p>
         </p:txBody>
@@ -8160,7 +8206,7 @@
                 <a:latin typeface="Times New Roman"/>
                 <a:cs typeface="Times New Roman"/>
               </a:rPr>
-              <a:t>systems applied in auditing: A systematic review.</a:t>
+              <a:t>systems applied in auditing: A systematic review. Scientific African, 25, e02281.</a:t>
             </a:r>
           </a:p>
         </p:txBody>

</xml_diff>